<commit_message>
Added turksih conference presentation
</commit_message>
<xml_diff>
--- a/EKG_Conference_Presentation.new.pptx
+++ b/EKG_Conference_Presentation.new.pptx
@@ -320,7 +320,7 @@
           <a:p>
             <a:fld id="{5BCAD085-E8A6-8845-BD4E-CB4CCA059FC4}" type="datetimeFigureOut">
               <a:rPr lang="en-US" smtClean="0"/>
-              <a:t>4/27/2026</a:t>
+              <a:t>5/18/2026</a:t>
             </a:fld>
             <a:endParaRPr lang="en-US"/>
           </a:p>
@@ -488,7 +488,7 @@
           <a:p>
             <a:fld id="{5BCAD085-E8A6-8845-BD4E-CB4CCA059FC4}" type="datetimeFigureOut">
               <a:rPr lang="en-US" smtClean="0"/>
-              <a:t>4/27/2026</a:t>
+              <a:t>5/18/2026</a:t>
             </a:fld>
             <a:endParaRPr lang="en-US"/>
           </a:p>
@@ -666,7 +666,7 @@
           <a:p>
             <a:fld id="{5BCAD085-E8A6-8845-BD4E-CB4CCA059FC4}" type="datetimeFigureOut">
               <a:rPr lang="en-US" smtClean="0"/>
-              <a:t>4/27/2026</a:t>
+              <a:t>5/18/2026</a:t>
             </a:fld>
             <a:endParaRPr lang="en-US"/>
           </a:p>
@@ -834,7 +834,7 @@
           <a:p>
             <a:fld id="{5BCAD085-E8A6-8845-BD4E-CB4CCA059FC4}" type="datetimeFigureOut">
               <a:rPr lang="en-US" smtClean="0"/>
-              <a:t>4/27/2026</a:t>
+              <a:t>5/18/2026</a:t>
             </a:fld>
             <a:endParaRPr lang="en-US"/>
           </a:p>
@@ -1079,7 +1079,7 @@
           <a:p>
             <a:fld id="{5BCAD085-E8A6-8845-BD4E-CB4CCA059FC4}" type="datetimeFigureOut">
               <a:rPr lang="en-US" smtClean="0"/>
-              <a:t>4/27/2026</a:t>
+              <a:t>5/18/2026</a:t>
             </a:fld>
             <a:endParaRPr lang="en-US"/>
           </a:p>
@@ -1364,7 +1364,7 @@
           <a:p>
             <a:fld id="{5BCAD085-E8A6-8845-BD4E-CB4CCA059FC4}" type="datetimeFigureOut">
               <a:rPr lang="en-US" smtClean="0"/>
-              <a:t>4/27/2026</a:t>
+              <a:t>5/18/2026</a:t>
             </a:fld>
             <a:endParaRPr lang="en-US"/>
           </a:p>
@@ -1783,7 +1783,7 @@
           <a:p>
             <a:fld id="{5BCAD085-E8A6-8845-BD4E-CB4CCA059FC4}" type="datetimeFigureOut">
               <a:rPr lang="en-US" smtClean="0"/>
-              <a:t>4/27/2026</a:t>
+              <a:t>5/18/2026</a:t>
             </a:fld>
             <a:endParaRPr lang="en-US"/>
           </a:p>
@@ -1900,7 +1900,7 @@
           <a:p>
             <a:fld id="{5BCAD085-E8A6-8845-BD4E-CB4CCA059FC4}" type="datetimeFigureOut">
               <a:rPr lang="en-US" smtClean="0"/>
-              <a:t>4/27/2026</a:t>
+              <a:t>5/18/2026</a:t>
             </a:fld>
             <a:endParaRPr lang="en-US"/>
           </a:p>
@@ -1995,7 +1995,7 @@
           <a:p>
             <a:fld id="{5BCAD085-E8A6-8845-BD4E-CB4CCA059FC4}" type="datetimeFigureOut">
               <a:rPr lang="en-US" smtClean="0"/>
-              <a:t>4/27/2026</a:t>
+              <a:t>5/18/2026</a:t>
             </a:fld>
             <a:endParaRPr lang="en-US"/>
           </a:p>
@@ -2270,7 +2270,7 @@
           <a:p>
             <a:fld id="{5BCAD085-E8A6-8845-BD4E-CB4CCA059FC4}" type="datetimeFigureOut">
               <a:rPr lang="en-US" smtClean="0"/>
-              <a:t>4/27/2026</a:t>
+              <a:t>5/18/2026</a:t>
             </a:fld>
             <a:endParaRPr lang="en-US"/>
           </a:p>
@@ -2522,7 +2522,7 @@
           <a:p>
             <a:fld id="{5BCAD085-E8A6-8845-BD4E-CB4CCA059FC4}" type="datetimeFigureOut">
               <a:rPr lang="en-US" smtClean="0"/>
-              <a:t>4/27/2026</a:t>
+              <a:t>5/18/2026</a:t>
             </a:fld>
             <a:endParaRPr lang="en-US"/>
           </a:p>
@@ -2733,7 +2733,7 @@
           <a:p>
             <a:fld id="{5BCAD085-E8A6-8845-BD4E-CB4CCA059FC4}" type="datetimeFigureOut">
               <a:rPr lang="en-US" smtClean="0"/>
-              <a:t>4/27/2026</a:t>
+              <a:t>5/18/2026</a:t>
             </a:fld>
             <a:endParaRPr lang="en-US"/>
           </a:p>
@@ -3336,41 +3336,6 @@
               </a:rPr>
               <a:t>Kyrgyz–Turkish Manas University · Dept. of Computer Engineering
 Thesis supervisor: Assoc. Prof. Bakıt Şarşembayev</a:t>
-            </a:r>
-          </a:p>
-        </p:txBody>
-      </p:sp>
-      <p:sp>
-        <p:nvSpPr>
-          <p:cNvPr id="8" name="TextBox 7"/>
-          <p:cNvSpPr txBox="1"/>
-          <p:nvPr/>
-        </p:nvSpPr>
-        <p:spPr>
-          <a:xfrm>
-            <a:off x="540000" y="6120000"/>
-            <a:ext cx="11112119" cy="360000"/>
-          </a:xfrm>
-          <a:prstGeom prst="rect">
-            <a:avLst/>
-          </a:prstGeom>
-          <a:noFill/>
-        </p:spPr>
-        <p:txBody>
-          <a:bodyPr wrap="square" lIns="0" tIns="0" rIns="0" bIns="0">
-            <a:spAutoFit/>
-          </a:bodyPr>
-          <a:lstStyle/>
-          <a:p>
-            <a:pPr algn="l"/>
-            <a:r>
-              <a:rPr sz="1400" b="0" i="1">
-                <a:solidFill>
-                  <a:srgbClr val="7F8C8D"/>
-                </a:solidFill>
-                <a:latin typeface="Calibri"/>
-              </a:rPr>
-              <a:t>Bahar 2026  ·  ICML-style submission draft</a:t>
             </a:r>
           </a:p>
         </p:txBody>
@@ -8744,7 +8709,7 @@
         <p:spPr>
           <a:xfrm>
             <a:off x="0" y="4320000"/>
-            <a:ext cx="12192119" cy="360000"/>
+            <a:ext cx="12192119" cy="215444"/>
           </a:xfrm>
           <a:prstGeom prst="rect">
             <a:avLst/>
@@ -8759,13 +8724,76 @@
           <a:p>
             <a:pPr algn="ctr"/>
             <a:r>
-              <a:rPr sz="1400" b="0" i="0">
+              <a:rPr sz="1400" b="0" i="0" dirty="0" err="1">
                 <a:solidFill>
                   <a:srgbClr val="DCE6F5"/>
                 </a:solidFill>
                 <a:latin typeface="Calibri"/>
               </a:rPr>
-              <a:t>Elaman Nazarkulov  ·  elaman.job@gmail.com  ·  KTMÜ</a:t>
+              <a:t>Elaman</a:t>
+            </a:r>
+            <a:r>
+              <a:rPr sz="1400" b="0" i="0" dirty="0">
+                <a:solidFill>
+                  <a:srgbClr val="DCE6F5"/>
+                </a:solidFill>
+                <a:latin typeface="Calibri"/>
+              </a:rPr>
+              <a:t> </a:t>
+            </a:r>
+            <a:r>
+              <a:rPr sz="1400" b="0" i="0" dirty="0" err="1">
+                <a:solidFill>
+                  <a:srgbClr val="DCE6F5"/>
+                </a:solidFill>
+                <a:latin typeface="Calibri"/>
+              </a:rPr>
+              <a:t>Nazarkulov</a:t>
+            </a:r>
+            <a:r>
+              <a:rPr sz="1400" b="0" i="0" dirty="0">
+                <a:solidFill>
+                  <a:srgbClr val="DCE6F5"/>
+                </a:solidFill>
+                <a:latin typeface="Calibri"/>
+              </a:rPr>
+              <a:t>  ·  </a:t>
+            </a:r>
+            <a:r>
+              <a:rPr lang="en-US" sz="1400" dirty="0">
+                <a:solidFill>
+                  <a:srgbClr val="DCE6F5"/>
+                </a:solidFill>
+                <a:latin typeface="Calibri"/>
+              </a:rPr>
+              <a:t>2351Y01005</a:t>
+            </a:r>
+            <a:r>
+              <a:rPr sz="1400" b="0" i="0" dirty="0">
+                <a:solidFill>
+                  <a:srgbClr val="DCE6F5"/>
+                </a:solidFill>
+                <a:latin typeface="Calibri"/>
+              </a:rPr>
+              <a:t>@</a:t>
+            </a:r>
+            <a:r>
+              <a:rPr lang="en-US" sz="1400" b="0" i="0" dirty="0">
+                <a:solidFill>
+                  <a:srgbClr val="DCE6F5"/>
+                </a:solidFill>
+                <a:latin typeface="Calibri"/>
+              </a:rPr>
+              <a:t>manas.edu.kg</a:t>
+            </a:r>
+            <a:r>
+              <a:rPr sz="1400" b="0" i="0" dirty="0">
+                <a:solidFill>
+                  <a:srgbClr val="DCE6F5"/>
+                </a:solidFill>
+                <a:latin typeface="Calibri"/>
+              </a:rPr>
+              <a:t>  ·  KTMÜ</a:t>
             </a:r>
           </a:p>
         </p:txBody>
@@ -8874,41 +8902,6 @@
                 <a:latin typeface="Calibri"/>
               </a:rPr>
               <a:t>Motivation</a:t>
-            </a:r>
-          </a:p>
-        </p:txBody>
-      </p:sp>
-      <p:sp>
-        <p:nvSpPr>
-          <p:cNvPr id="4" name="TextBox 3"/>
-          <p:cNvSpPr txBox="1"/>
-          <p:nvPr/>
-        </p:nvSpPr>
-        <p:spPr>
-          <a:xfrm>
-            <a:off x="360000" y="684000"/>
-            <a:ext cx="11520000" cy="360000"/>
-          </a:xfrm>
-          <a:prstGeom prst="rect">
-            <a:avLst/>
-          </a:prstGeom>
-          <a:noFill/>
-        </p:spPr>
-        <p:txBody>
-          <a:bodyPr wrap="square" lIns="0" tIns="0" rIns="0" bIns="0">
-            <a:spAutoFit/>
-          </a:bodyPr>
-          <a:lstStyle/>
-          <a:p>
-            <a:pPr algn="l"/>
-            <a:r>
-              <a:rPr sz="1400" b="0" i="1">
-                <a:solidFill>
-                  <a:srgbClr val="7F8C8D"/>
-                </a:solidFill>
-                <a:latin typeface="Calibri"/>
-              </a:rPr>
-              <a:t>Why a baseline that should have been a non-issue turned into the main finding</a:t>
             </a:r>
           </a:p>
         </p:txBody>

</xml_diff>